<commit_message>
Design review deck: larger, split class diagrams; zoomed architecture
- Split the host-side, core and boundary-type class diagrams into
  smaller diagrams, one per slide, so each fills the slide width.
- Added zoomed host PC and Raspberry Pi crops of the architecture
  diagram, following hand edits to the deck.
- Diagram slides start right under the title bar; edge-to-edge slides
  drop the footer.
- Removed in-image titles from every diagram (the slide and SDD
  headings name them).
</commit_message>
<xml_diff>
--- a/documents/slides/design_review_template.pptx
+++ b/documents/slides/design_review_template.pptx
@@ -4760,8 +4760,8 @@
         </p:blipFill>
         <p:spPr>
           <a:xfrm>
-            <a:off x="2558854" y="1097280"/>
-            <a:ext cx="7073986" cy="4937760"/>
+            <a:off x="2240474" y="978408"/>
+            <a:ext cx="7710747" cy="5056632"/>
           </a:xfrm>
           <a:prstGeom prst="rect">
             <a:avLst/>

</xml_diff>

<commit_message>
Combined SDD: bring in every module's design files from its branch, and the system architecture
</commit_message>
<xml_diff>
--- a/documents/slides/design_review_template.pptx
+++ b/documents/slides/design_review_template.pptx
@@ -4760,8 +4760,8 @@
         </p:blipFill>
         <p:spPr>
           <a:xfrm>
-            <a:off x="2558854" y="1097280"/>
-            <a:ext cx="7073986" cy="4937760"/>
+            <a:off x="2240474" y="978408"/>
+            <a:ext cx="7710747" cy="5056632"/>
           </a:xfrm>
           <a:prstGeom prst="rect">
             <a:avLst/>

</xml_diff>